<commit_message>
Refresh the coaching-management pitch deck's screenshots and copy for current features
Every dashboard/public-page screenshot in the deck predated this
project's recent UI work, so they all showed the old top-nav header,
"Announcements" labeling, and the old click-through Materials view.
Recaptured all 12 affected screenshots (hero, course detail, search,
Online Class, all four role dashboards, student dashboard, Materials +
Ask Question, and the App Notifications composer) straight from the
running app, and updated the slide copy that named the old
"Announcements" feature to "App Notifications" plus a mention of the
new homepage banner. Regenerated the PDF from the updated deck and
copied both into public/files.
</commit_message>
<xml_diff>
--- a/public/files/coaching-management-platform-pitch.pptx
+++ b/public/files/coaching-management-platform-pitch.pptx
@@ -6849,7 +6849,7 @@
                 <a:ea typeface="Calibri" pitchFamily="34" charset="-122"/>
                 <a:cs typeface="Calibri" pitchFamily="34" charset="-120"/>
               </a:rPr>
-              <a:t>Announcements, Ask Question &amp; push notifications</a:t>
+              <a:t>App Notifications, Ask Question &amp; a homepage banner</a:t>
             </a:r>
             <a:endParaRPr lang="en-US" sz="1100" dirty="0"/>
           </a:p>
@@ -13486,7 +13486,7 @@
                 <a:ea typeface="Calibri" pitchFamily="34" charset="-122"/>
                 <a:cs typeface="Calibri" pitchFamily="34" charset="-120"/>
               </a:rPr>
-              <a:t>Course Materials: recordings and files, with Ask Question embedded right below — scoped to that course</a:t>
+              <a:t>Materials: recordings and files, with Ask Question embedded right below — scoped to that course</a:t>
             </a:r>
             <a:endParaRPr lang="en-US" sz="1050" dirty="0"/>
           </a:p>
@@ -13640,7 +13640,7 @@
                 <a:ea typeface="Cambria" pitchFamily="34" charset="-122"/>
                 <a:cs typeface="Cambria" pitchFamily="34" charset="-120"/>
               </a:rPr>
-              <a:t>Announcements and doubts, built in</a:t>
+              <a:t>App Notifications and doubts, built in</a:t>
             </a:r>
             <a:endParaRPr lang="en-US" sz="2600" dirty="0"/>
           </a:p>
@@ -13776,7 +13776,7 @@
                 <a:ea typeface="Calibri" pitchFamily="34" charset="-122"/>
                 <a:cs typeface="Calibri" pitchFamily="34" charset="-120"/>
               </a:rPr>
-              <a:t>Announcements: five audience options, replies, and 👍 reactions</a:t>
+              <a:t>App Notifications: five audience options, replies, and 👍 reactions</a:t>
             </a:r>
             <a:endParaRPr lang="en-US" sz="1050" dirty="0"/>
           </a:p>

</xml_diff>